<commit_message>
Simplifica linguagem das limitacoes no slide final
Reescreve os 3 cards de limitacao com frases mais diretas e faladas,
mais faceis de explicar no video executivo.

Co-Authored-By: Claude Sonnet 5 <noreply@anthropic.com>
</commit_message>
<xml_diff>
--- a/Tech_Challenge_Fase1.pptx
+++ b/Tech_Challenge_Fase1.pptx
@@ -7501,7 +7501,7 @@
                 </a:solidFill>
                 <a:latin typeface="Aptos"/>
               </a:rPr>
-              <a:t>o padrão atraso → reclamação → detrator é consistente nos dados, mas não foi testado em um experimento controlado.</a:t>
+              <a:t>Atraso, reclamação e nota baixa andam juntos nos dados — mas isso não prova, sozinho, que um causa o outro.</a:t>
             </a:r>
           </a:p>
         </p:txBody>
@@ -7673,7 +7673,7 @@
                 </a:solidFill>
                 <a:latin typeface="Aptos"/>
               </a:rPr>
-              <a:t>os dados não incorporam sazonalidade, concorrência ou tipo de produto vendido.</a:t>
+              <a:t>Os dados são de um período fixo e não mostram época do ano, concorrência ou tipo de produto vendido.</a:t>
             </a:r>
           </a:p>
         </p:txBody>
@@ -7845,7 +7845,7 @@
                 </a:solidFill>
                 <a:latin typeface="Aptos"/>
               </a:rPr>
-              <a:t>83,1% dos pedidos são detratores, o que exige cautela ao validar conclusões sobre a minoria de promotores.</a:t>
+              <a:t>Só 106 pedidos (4,8%) são de promotores — poucos casos para afirmar com certeza total o que os deixa satisfeitos.</a:t>
             </a:r>
           </a:p>
         </p:txBody>

</xml_diff>

<commit_message>
Adiciona slide de abertura (capa) e encerramento a apresentacao
Capa com titulo do projeto, equipe e escopo da analise; slide final
de encerramento com link do repositorio e espaco para perguntas.
Deck passa de 10 para 12 slides, mantendo os 10 slides de conteudo
inalterados no meio.

Co-Authored-By: Claude Sonnet 5 <noreply@anthropic.com>
</commit_message>
<xml_diff>
--- a/Tech_Challenge_Fase1.pptx
+++ b/Tech_Challenge_Fase1.pptx
@@ -8,6 +8,7 @@
     <p:notesMasterId r:id="rId6"/>
   </p:notesMasterIdLst>
   <p:sldIdLst>
+    <p:sldId id="266" r:id="rId17"/>
     <p:sldId id="256" r:id="rId2"/>
     <p:sldId id="257" r:id="rId3"/>
     <p:sldId id="258" r:id="rId4"/>
@@ -18,6 +19,7 @@
     <p:sldId id="263" r:id="rId14"/>
     <p:sldId id="264" r:id="rId15"/>
     <p:sldId id="265" r:id="rId16"/>
+    <p:sldId id="267" r:id="rId18"/>
   </p:sldIdLst>
   <p:sldSz cx="12192000" cy="6858000"/>
   <p:notesSz cx="6858000" cy="12192000"/>
@@ -8057,6 +8059,974 @@
 </p:sld>
 </file>
 
+<file path=ppt/slides/slide11.xml><?xml version="1.0" encoding="utf-8"?>
+<p:sld xmlns:a="http://schemas.openxmlformats.org/drawingml/2006/main" xmlns:p="http://schemas.openxmlformats.org/presentationml/2006/main" xmlns:r="http://schemas.openxmlformats.org/officeDocument/2006/relationships">
+  <p:cSld>
+    <p:bg>
+      <p:bgPr>
+        <a:solidFill>
+          <a:srgbClr val="091220"/>
+        </a:solidFill>
+        <a:effectLst/>
+      </p:bgPr>
+    </p:bg>
+    <p:spTree>
+      <p:nvGrpSpPr>
+        <p:cNvPr id="1" name=""/>
+        <p:cNvGrpSpPr/>
+        <p:nvPr/>
+      </p:nvGrpSpPr>
+      <p:grpSpPr/>
+      <p:sp>
+        <p:nvSpPr>
+          <p:cNvPr id="2" name="TextBox 1"/>
+          <p:cNvSpPr txBox="1"/>
+          <p:nvPr/>
+        </p:nvSpPr>
+        <p:spPr>
+          <a:xfrm>
+            <a:off x="658368" y="777240"/>
+            <a:ext cx="5943600" cy="219456"/>
+          </a:xfrm>
+          <a:prstGeom prst="rect">
+            <a:avLst/>
+          </a:prstGeom>
+          <a:noFill/>
+        </p:spPr>
+        <p:txBody>
+          <a:bodyPr wrap="square" anchor="t" lIns="0" rIns="0" tIns="0" bIns="0">
+            <a:spAutoFit/>
+          </a:bodyPr>
+          <a:lstStyle/>
+          <a:p>
+            <a:pPr algn="l"/>
+            <a:r>
+              <a:rPr sz="1000" b="1" i="0">
+                <a:solidFill>
+                  <a:srgbClr val="25C7E5"/>
+                </a:solidFill>
+                <a:latin typeface="Aptos"/>
+              </a:rPr>
+              <a:t>POS TECH  ·  TECH CHALLENGE FASE 1</a:t>
+            </a:r>
+          </a:p>
+        </p:txBody>
+      </p:sp>
+      <p:sp>
+        <p:nvSpPr>
+          <p:cNvPr id="3" name="TextBox 2"/>
+          <p:cNvSpPr txBox="1"/>
+          <p:nvPr/>
+        </p:nvSpPr>
+        <p:spPr>
+          <a:xfrm>
+            <a:off x="640080" y="2331720"/>
+            <a:ext cx="7315200" cy="1051560"/>
+          </a:xfrm>
+          <a:prstGeom prst="rect">
+            <a:avLst/>
+          </a:prstGeom>
+          <a:noFill/>
+        </p:spPr>
+        <p:txBody>
+          <a:bodyPr wrap="square" anchor="t" lIns="0" rIns="0" tIns="0" bIns="0">
+            <a:spAutoFit/>
+          </a:bodyPr>
+          <a:lstStyle/>
+          <a:p>
+            <a:pPr algn="l"/>
+            <a:r>
+              <a:rPr sz="5800" b="1" i="0">
+                <a:solidFill>
+                  <a:srgbClr val="FFFFFF"/>
+                </a:solidFill>
+                <a:latin typeface="Aptos Display"/>
+              </a:rPr>
+              <a:t>NPS Preditivo</a:t>
+            </a:r>
+          </a:p>
+        </p:txBody>
+      </p:sp>
+      <p:sp>
+        <p:nvSpPr>
+          <p:cNvPr id="4" name="TextBox 3"/>
+          <p:cNvSpPr txBox="1"/>
+          <p:nvPr/>
+        </p:nvSpPr>
+        <p:spPr>
+          <a:xfrm>
+            <a:off x="658368" y="3520440"/>
+            <a:ext cx="6675120" cy="685800"/>
+          </a:xfrm>
+          <a:prstGeom prst="rect">
+            <a:avLst/>
+          </a:prstGeom>
+          <a:noFill/>
+        </p:spPr>
+        <p:txBody>
+          <a:bodyPr wrap="square" anchor="t" lIns="0" rIns="0" tIns="0" bIns="0">
+            <a:spAutoFit/>
+          </a:bodyPr>
+          <a:lstStyle/>
+          <a:p>
+            <a:pPr algn="l">
+              <a:lnSpc>
+                <a:spcPct val="120000"/>
+              </a:lnSpc>
+            </a:pPr>
+            <a:r>
+              <a:rPr sz="1450" b="0" i="0">
+                <a:solidFill>
+                  <a:srgbClr val="9FB0C6"/>
+                </a:solidFill>
+                <a:latin typeface="Aptos"/>
+              </a:rPr>
+              <a:t>Fatores operacionais que explicam a satisfação do cliente — e como agir antes de o NPS cair.</a:t>
+            </a:r>
+          </a:p>
+        </p:txBody>
+      </p:sp>
+      <p:cxnSp>
+        <p:nvCxnSpPr>
+          <p:cNvPr id="5" name="Connector 4"/>
+          <p:cNvCxnSpPr/>
+          <p:nvPr/>
+        </p:nvCxnSpPr>
+        <p:spPr>
+          <a:xfrm>
+            <a:off x="667512" y="4434840"/>
+            <a:ext cx="6647688" cy="0"/>
+          </a:xfrm>
+          <a:prstGeom prst="line">
+            <a:avLst/>
+          </a:prstGeom>
+          <a:ln w="9525">
+            <a:solidFill>
+              <a:srgbClr val="263951"/>
+            </a:solidFill>
+          </a:ln>
+          <a:effectLst/>
+        </p:spPr>
+        <p:style>
+          <a:lnRef idx="2">
+            <a:schemeClr val="accent1"/>
+          </a:lnRef>
+          <a:fillRef idx="0">
+            <a:schemeClr val="accent1"/>
+          </a:fillRef>
+          <a:effectRef idx="1">
+            <a:schemeClr val="accent1"/>
+          </a:effectRef>
+          <a:fontRef idx="minor">
+            <a:schemeClr val="tx1"/>
+          </a:fontRef>
+        </p:style>
+      </p:cxnSp>
+      <p:sp>
+        <p:nvSpPr>
+          <p:cNvPr id="6" name="TextBox 5"/>
+          <p:cNvSpPr txBox="1"/>
+          <p:nvPr/>
+        </p:nvSpPr>
+        <p:spPr>
+          <a:xfrm>
+            <a:off x="658368" y="4645152"/>
+            <a:ext cx="1828800" cy="201168"/>
+          </a:xfrm>
+          <a:prstGeom prst="rect">
+            <a:avLst/>
+          </a:prstGeom>
+          <a:noFill/>
+        </p:spPr>
+        <p:txBody>
+          <a:bodyPr wrap="square" anchor="t" lIns="0" rIns="0" tIns="0" bIns="0">
+            <a:spAutoFit/>
+          </a:bodyPr>
+          <a:lstStyle/>
+          <a:p>
+            <a:pPr algn="l"/>
+            <a:r>
+              <a:rPr sz="940" b="1" i="0">
+                <a:solidFill>
+                  <a:srgbClr val="25C7E5"/>
+                </a:solidFill>
+                <a:latin typeface="Aptos"/>
+              </a:rPr>
+              <a:t>EQUIPE</a:t>
+            </a:r>
+          </a:p>
+        </p:txBody>
+      </p:sp>
+      <p:sp>
+        <p:nvSpPr>
+          <p:cNvPr id="7" name="TextBox 6"/>
+          <p:cNvSpPr txBox="1"/>
+          <p:nvPr/>
+        </p:nvSpPr>
+        <p:spPr>
+          <a:xfrm>
+            <a:off x="658368" y="4901184"/>
+            <a:ext cx="6766560" cy="502920"/>
+          </a:xfrm>
+          <a:prstGeom prst="rect">
+            <a:avLst/>
+          </a:prstGeom>
+          <a:noFill/>
+        </p:spPr>
+        <p:txBody>
+          <a:bodyPr wrap="square" anchor="t" lIns="0" rIns="0" tIns="0" bIns="0">
+            <a:spAutoFit/>
+          </a:bodyPr>
+          <a:lstStyle/>
+          <a:p>
+            <a:pPr algn="l">
+              <a:lnSpc>
+                <a:spcPct val="125000"/>
+              </a:lnSpc>
+            </a:pPr>
+            <a:r>
+              <a:rPr sz="1220" b="0" i="0">
+                <a:solidFill>
+                  <a:srgbClr val="FFFFFF"/>
+                </a:solidFill>
+                <a:latin typeface="Aptos"/>
+              </a:rPr>
+              <a:t>Amanda Alves de Lima Santos  ·  Fábio da Silva Costa  ·  Gabriel Victor  ·  Vanessa Partala</a:t>
+            </a:r>
+          </a:p>
+        </p:txBody>
+      </p:sp>
+      <p:cxnSp>
+        <p:nvCxnSpPr>
+          <p:cNvPr id="8" name="Connector 7"/>
+          <p:cNvCxnSpPr/>
+          <p:nvPr/>
+        </p:nvCxnSpPr>
+        <p:spPr>
+          <a:xfrm>
+            <a:off x="8275320" y="2331720"/>
+            <a:ext cx="0" cy="2377440"/>
+          </a:xfrm>
+          <a:prstGeom prst="line">
+            <a:avLst/>
+          </a:prstGeom>
+          <a:ln w="9525">
+            <a:solidFill>
+              <a:srgbClr val="263951"/>
+            </a:solidFill>
+          </a:ln>
+          <a:effectLst/>
+        </p:spPr>
+        <p:style>
+          <a:lnRef idx="2">
+            <a:schemeClr val="accent1"/>
+          </a:lnRef>
+          <a:fillRef idx="0">
+            <a:schemeClr val="accent1"/>
+          </a:fillRef>
+          <a:effectRef idx="1">
+            <a:schemeClr val="accent1"/>
+          </a:effectRef>
+          <a:fontRef idx="minor">
+            <a:schemeClr val="tx1"/>
+          </a:fontRef>
+        </p:style>
+      </p:cxnSp>
+      <p:sp>
+        <p:nvSpPr>
+          <p:cNvPr id="9" name="TextBox 8"/>
+          <p:cNvSpPr txBox="1"/>
+          <p:nvPr/>
+        </p:nvSpPr>
+        <p:spPr>
+          <a:xfrm>
+            <a:off x="8641080" y="2377440"/>
+            <a:ext cx="2743200" cy="219456"/>
+          </a:xfrm>
+          <a:prstGeom prst="rect">
+            <a:avLst/>
+          </a:prstGeom>
+          <a:noFill/>
+        </p:spPr>
+        <p:txBody>
+          <a:bodyPr wrap="square" anchor="t" lIns="0" rIns="0" tIns="0" bIns="0">
+            <a:spAutoFit/>
+          </a:bodyPr>
+          <a:lstStyle/>
+          <a:p>
+            <a:pPr algn="l"/>
+            <a:r>
+              <a:rPr sz="940" b="1" i="0">
+                <a:solidFill>
+                  <a:srgbClr val="25C7E5"/>
+                </a:solidFill>
+                <a:latin typeface="Aptos"/>
+              </a:rPr>
+              <a:t>ESCOPO DA ANÁLISE</a:t>
+            </a:r>
+          </a:p>
+        </p:txBody>
+      </p:sp>
+      <p:sp>
+        <p:nvSpPr>
+          <p:cNvPr id="10" name="TextBox 9"/>
+          <p:cNvSpPr txBox="1"/>
+          <p:nvPr/>
+        </p:nvSpPr>
+        <p:spPr>
+          <a:xfrm>
+            <a:off x="8613648" y="2670048"/>
+            <a:ext cx="2743200" cy="685800"/>
+          </a:xfrm>
+          <a:prstGeom prst="rect">
+            <a:avLst/>
+          </a:prstGeom>
+          <a:noFill/>
+        </p:spPr>
+        <p:txBody>
+          <a:bodyPr wrap="square" anchor="t" lIns="0" rIns="0" tIns="0" bIns="0">
+            <a:spAutoFit/>
+          </a:bodyPr>
+          <a:lstStyle/>
+          <a:p>
+            <a:pPr algn="l"/>
+            <a:r>
+              <a:rPr sz="4400" b="1" i="0">
+                <a:solidFill>
+                  <a:srgbClr val="FFFFFF"/>
+                </a:solidFill>
+                <a:latin typeface="Aptos Display"/>
+              </a:rPr>
+              <a:t>2.202</a:t>
+            </a:r>
+          </a:p>
+        </p:txBody>
+      </p:sp>
+      <p:sp>
+        <p:nvSpPr>
+          <p:cNvPr id="11" name="TextBox 10"/>
+          <p:cNvSpPr txBox="1"/>
+          <p:nvPr/>
+        </p:nvSpPr>
+        <p:spPr>
+          <a:xfrm>
+            <a:off x="8641080" y="3401568"/>
+            <a:ext cx="2743200" cy="237744"/>
+          </a:xfrm>
+          <a:prstGeom prst="rect">
+            <a:avLst/>
+          </a:prstGeom>
+          <a:noFill/>
+        </p:spPr>
+        <p:txBody>
+          <a:bodyPr wrap="square" anchor="t" lIns="0" rIns="0" tIns="0" bIns="0">
+            <a:spAutoFit/>
+          </a:bodyPr>
+          <a:lstStyle/>
+          <a:p>
+            <a:pPr algn="l"/>
+            <a:r>
+              <a:rPr sz="1150" b="0" i="0">
+                <a:solidFill>
+                  <a:srgbClr val="9FB0C6"/>
+                </a:solidFill>
+                <a:latin typeface="Aptos"/>
+              </a:rPr>
+              <a:t>pedidos tratados</a:t>
+            </a:r>
+          </a:p>
+        </p:txBody>
+      </p:sp>
+      <p:sp>
+        <p:nvSpPr>
+          <p:cNvPr id="12" name="Rounded Rectangle 11"/>
+          <p:cNvSpPr/>
+          <p:nvPr/>
+        </p:nvSpPr>
+        <p:spPr>
+          <a:xfrm>
+            <a:off x="8641080" y="3767328"/>
+            <a:ext cx="2331720" cy="310896"/>
+          </a:xfrm>
+          <a:prstGeom prst="roundRect">
+            <a:avLst>
+              <a:gd name="adj" fmla="val 50000"/>
+            </a:avLst>
+          </a:prstGeom>
+          <a:solidFill>
+            <a:srgbClr val="331A25"/>
+          </a:solidFill>
+          <a:ln>
+            <a:noFill/>
+          </a:ln>
+          <a:effectLst/>
+        </p:spPr>
+        <p:style>
+          <a:lnRef idx="1">
+            <a:schemeClr val="accent1"/>
+          </a:lnRef>
+          <a:fillRef idx="3">
+            <a:schemeClr val="accent1"/>
+          </a:fillRef>
+          <a:effectRef idx="2">
+            <a:schemeClr val="accent1"/>
+          </a:effectRef>
+          <a:fontRef idx="minor">
+            <a:schemeClr val="lt1"/>
+          </a:fontRef>
+        </p:style>
+        <p:txBody>
+          <a:bodyPr rtlCol="0" anchor="ctr"/>
+          <a:lstStyle/>
+          <a:p>
+            <a:pPr algn="ctr"/>
+          </a:p>
+        </p:txBody>
+      </p:sp>
+      <p:sp>
+        <p:nvSpPr>
+          <p:cNvPr id="13" name="TextBox 12"/>
+          <p:cNvSpPr txBox="1"/>
+          <p:nvPr/>
+        </p:nvSpPr>
+        <p:spPr>
+          <a:xfrm>
+            <a:off x="8641080" y="3785615"/>
+            <a:ext cx="2331720" cy="274320"/>
+          </a:xfrm>
+          <a:prstGeom prst="rect">
+            <a:avLst/>
+          </a:prstGeom>
+          <a:noFill/>
+        </p:spPr>
+        <p:txBody>
+          <a:bodyPr wrap="square" anchor="t" lIns="0" rIns="0" tIns="0" bIns="0">
+            <a:spAutoFit/>
+          </a:bodyPr>
+          <a:lstStyle/>
+          <a:p>
+            <a:pPr algn="ctr"/>
+            <a:r>
+              <a:rPr sz="930" b="1" i="0">
+                <a:solidFill>
+                  <a:srgbClr val="F6A5AA"/>
+                </a:solidFill>
+                <a:latin typeface="Aptos"/>
+              </a:rPr>
+              <a:t>83,1% são detratores hoje</a:t>
+            </a:r>
+          </a:p>
+        </p:txBody>
+      </p:sp>
+      <p:sp>
+        <p:nvSpPr>
+          <p:cNvPr id="14" name="TextBox 13"/>
+          <p:cNvSpPr txBox="1"/>
+          <p:nvPr/>
+        </p:nvSpPr>
+        <p:spPr>
+          <a:xfrm>
+            <a:off x="658368" y="6501384"/>
+            <a:ext cx="5486400" cy="182880"/>
+          </a:xfrm>
+          <a:prstGeom prst="rect">
+            <a:avLst/>
+          </a:prstGeom>
+          <a:noFill/>
+        </p:spPr>
+        <p:txBody>
+          <a:bodyPr wrap="square" anchor="t" lIns="0" rIns="0" tIns="0" bIns="0">
+            <a:spAutoFit/>
+          </a:bodyPr>
+          <a:lstStyle/>
+          <a:p>
+            <a:pPr algn="l"/>
+            <a:r>
+              <a:rPr sz="850" b="0" i="0">
+                <a:solidFill>
+                  <a:srgbClr val="718399"/>
+                </a:solidFill>
+                <a:latin typeface="Aptos"/>
+              </a:rPr>
+              <a:t>Case NPS Preditivo  ·  Business Understanding &amp; Data Analysis</a:t>
+            </a:r>
+          </a:p>
+        </p:txBody>
+      </p:sp>
+    </p:spTree>
+  </p:cSld>
+  <p:clrMapOvr>
+    <a:masterClrMapping/>
+  </p:clrMapOvr>
+</p:sld>
+</file>
+
+<file path=ppt/slides/slide12.xml><?xml version="1.0" encoding="utf-8"?>
+<p:sld xmlns:a="http://schemas.openxmlformats.org/drawingml/2006/main" xmlns:p="http://schemas.openxmlformats.org/presentationml/2006/main" xmlns:r="http://schemas.openxmlformats.org/officeDocument/2006/relationships">
+  <p:cSld>
+    <p:bg>
+      <p:bgPr>
+        <a:solidFill>
+          <a:srgbClr val="091220"/>
+        </a:solidFill>
+        <a:effectLst/>
+      </p:bgPr>
+    </p:bg>
+    <p:spTree>
+      <p:nvGrpSpPr>
+        <p:cNvPr id="1" name=""/>
+        <p:cNvGrpSpPr/>
+        <p:nvPr/>
+      </p:nvGrpSpPr>
+      <p:grpSpPr/>
+      <p:sp>
+        <p:nvSpPr>
+          <p:cNvPr id="2" name="TextBox 1"/>
+          <p:cNvSpPr txBox="1"/>
+          <p:nvPr/>
+        </p:nvSpPr>
+        <p:spPr>
+          <a:xfrm>
+            <a:off x="658368" y="685800"/>
+            <a:ext cx="5943600" cy="219456"/>
+          </a:xfrm>
+          <a:prstGeom prst="rect">
+            <a:avLst/>
+          </a:prstGeom>
+          <a:noFill/>
+        </p:spPr>
+        <p:txBody>
+          <a:bodyPr wrap="square" anchor="t" lIns="0" rIns="0" tIns="0" bIns="0">
+            <a:spAutoFit/>
+          </a:bodyPr>
+          <a:lstStyle/>
+          <a:p>
+            <a:pPr algn="l"/>
+            <a:r>
+              <a:rPr sz="1000" b="1" i="0">
+                <a:solidFill>
+                  <a:srgbClr val="25C7E5"/>
+                </a:solidFill>
+                <a:latin typeface="Aptos"/>
+              </a:rPr>
+              <a:t>OBRIGADO</a:t>
+            </a:r>
+          </a:p>
+        </p:txBody>
+      </p:sp>
+      <p:sp>
+        <p:nvSpPr>
+          <p:cNvPr id="3" name="TextBox 2"/>
+          <p:cNvSpPr txBox="1"/>
+          <p:nvPr/>
+        </p:nvSpPr>
+        <p:spPr>
+          <a:xfrm>
+            <a:off x="640080" y="1417320"/>
+            <a:ext cx="8686800" cy="960120"/>
+          </a:xfrm>
+          <a:prstGeom prst="rect">
+            <a:avLst/>
+          </a:prstGeom>
+          <a:noFill/>
+        </p:spPr>
+        <p:txBody>
+          <a:bodyPr wrap="square" anchor="t" lIns="0" rIns="0" tIns="0" bIns="0">
+            <a:spAutoFit/>
+          </a:bodyPr>
+          <a:lstStyle/>
+          <a:p>
+            <a:pPr algn="l">
+              <a:lnSpc>
+                <a:spcPct val="105000"/>
+              </a:lnSpc>
+            </a:pPr>
+            <a:r>
+              <a:rPr sz="3400" b="1" i="0">
+                <a:solidFill>
+                  <a:srgbClr val="FFFFFF"/>
+                </a:solidFill>
+                <a:latin typeface="Aptos Display"/>
+              </a:rPr>
+              <a:t>Sabemos o que muda o NPS. Agora é decidir o que priorizar.</a:t>
+            </a:r>
+          </a:p>
+        </p:txBody>
+      </p:sp>
+      <p:sp>
+        <p:nvSpPr>
+          <p:cNvPr id="4" name="TextBox 3"/>
+          <p:cNvSpPr txBox="1"/>
+          <p:nvPr/>
+        </p:nvSpPr>
+        <p:spPr>
+          <a:xfrm>
+            <a:off x="658368" y="2606040"/>
+            <a:ext cx="8961120" cy="457200"/>
+          </a:xfrm>
+          <a:prstGeom prst="rect">
+            <a:avLst/>
+          </a:prstGeom>
+          <a:noFill/>
+        </p:spPr>
+        <p:txBody>
+          <a:bodyPr wrap="square" anchor="t" lIns="0" rIns="0" tIns="0" bIns="0">
+            <a:spAutoFit/>
+          </a:bodyPr>
+          <a:lstStyle/>
+          <a:p>
+            <a:pPr algn="l">
+              <a:lnSpc>
+                <a:spcPct val="120000"/>
+              </a:lnSpc>
+            </a:pPr>
+            <a:r>
+              <a:rPr sz="1300" b="0" i="0">
+                <a:solidFill>
+                  <a:srgbClr val="9FB0C6"/>
+                </a:solidFill>
+                <a:latin typeface="Aptos"/>
+              </a:rPr>
+              <a:t>Notebooks, base tratada e este material completo estão no repositório público do projeto.</a:t>
+            </a:r>
+          </a:p>
+        </p:txBody>
+      </p:sp>
+      <p:sp>
+        <p:nvSpPr>
+          <p:cNvPr id="5" name="Rounded Rectangle 4"/>
+          <p:cNvSpPr/>
+          <p:nvPr/>
+        </p:nvSpPr>
+        <p:spPr>
+          <a:xfrm>
+            <a:off x="658368" y="3429000"/>
+            <a:ext cx="10881360" cy="1417320"/>
+          </a:xfrm>
+          <a:prstGeom prst="roundRect">
+            <a:avLst>
+              <a:gd name="adj" fmla="val 4500"/>
+            </a:avLst>
+          </a:prstGeom>
+          <a:solidFill>
+            <a:srgbClr val="0D1A2B"/>
+          </a:solidFill>
+          <a:ln>
+            <a:noFill/>
+          </a:ln>
+          <a:effectLst/>
+        </p:spPr>
+        <p:style>
+          <a:lnRef idx="1">
+            <a:schemeClr val="accent1"/>
+          </a:lnRef>
+          <a:fillRef idx="3">
+            <a:schemeClr val="accent1"/>
+          </a:fillRef>
+          <a:effectRef idx="2">
+            <a:schemeClr val="accent1"/>
+          </a:effectRef>
+          <a:fontRef idx="minor">
+            <a:schemeClr val="lt1"/>
+          </a:fontRef>
+        </p:style>
+        <p:txBody>
+          <a:bodyPr rtlCol="0" anchor="ctr"/>
+          <a:lstStyle/>
+          <a:p>
+            <a:pPr algn="ctr"/>
+          </a:p>
+        </p:txBody>
+      </p:sp>
+      <p:sp>
+        <p:nvSpPr>
+          <p:cNvPr id="6" name="TextBox 5"/>
+          <p:cNvSpPr txBox="1"/>
+          <p:nvPr/>
+        </p:nvSpPr>
+        <p:spPr>
+          <a:xfrm>
+            <a:off x="960120" y="3666744"/>
+            <a:ext cx="2743200" cy="219456"/>
+          </a:xfrm>
+          <a:prstGeom prst="rect">
+            <a:avLst/>
+          </a:prstGeom>
+          <a:noFill/>
+        </p:spPr>
+        <p:txBody>
+          <a:bodyPr wrap="square" anchor="t" lIns="0" rIns="0" tIns="0" bIns="0">
+            <a:spAutoFit/>
+          </a:bodyPr>
+          <a:lstStyle/>
+          <a:p>
+            <a:pPr algn="l"/>
+            <a:r>
+              <a:rPr sz="940" b="1" i="0">
+                <a:solidFill>
+                  <a:srgbClr val="25C7E5"/>
+                </a:solidFill>
+                <a:latin typeface="Aptos"/>
+              </a:rPr>
+              <a:t>REPOSITÓRIO GITHUB</a:t>
+            </a:r>
+          </a:p>
+        </p:txBody>
+      </p:sp>
+      <p:sp>
+        <p:nvSpPr>
+          <p:cNvPr id="7" name="TextBox 6"/>
+          <p:cNvSpPr txBox="1"/>
+          <p:nvPr/>
+        </p:nvSpPr>
+        <p:spPr>
+          <a:xfrm>
+            <a:off x="960120" y="3941064"/>
+            <a:ext cx="9966960" cy="365760"/>
+          </a:xfrm>
+          <a:prstGeom prst="rect">
+            <a:avLst/>
+          </a:prstGeom>
+          <a:noFill/>
+        </p:spPr>
+        <p:txBody>
+          <a:bodyPr wrap="square" anchor="t" lIns="0" rIns="0" tIns="0" bIns="0">
+            <a:spAutoFit/>
+          </a:bodyPr>
+          <a:lstStyle/>
+          <a:p>
+            <a:pPr algn="l"/>
+            <a:r>
+              <a:rPr sz="1400" b="1" i="0">
+                <a:solidFill>
+                  <a:srgbClr val="87E5F2"/>
+                </a:solidFill>
+                <a:latin typeface="Aptos"/>
+              </a:rPr>
+              <a:t>github.com/Fabio-Costa986/Business-understanding-and-data-analysis</a:t>
+            </a:r>
+          </a:p>
+        </p:txBody>
+      </p:sp>
+      <p:sp>
+        <p:nvSpPr>
+          <p:cNvPr id="8" name="TextBox 7"/>
+          <p:cNvSpPr txBox="1"/>
+          <p:nvPr/>
+        </p:nvSpPr>
+        <p:spPr>
+          <a:xfrm>
+            <a:off x="960120" y="4361688"/>
+            <a:ext cx="9966960" cy="320040"/>
+          </a:xfrm>
+          <a:prstGeom prst="rect">
+            <a:avLst/>
+          </a:prstGeom>
+          <a:noFill/>
+        </p:spPr>
+        <p:txBody>
+          <a:bodyPr wrap="square" anchor="t" lIns="0" rIns="0" tIns="0" bIns="0">
+            <a:spAutoFit/>
+          </a:bodyPr>
+          <a:lstStyle/>
+          <a:p>
+            <a:pPr algn="l"/>
+            <a:r>
+              <a:rPr sz="1050" b="0" i="0">
+                <a:solidFill>
+                  <a:srgbClr val="A6B4C6"/>
+                </a:solidFill>
+                <a:latin typeface="Aptos"/>
+              </a:rPr>
+              <a:t>Tratamento de dados · EDA completa · slides · vídeo executivo</a:t>
+            </a:r>
+          </a:p>
+        </p:txBody>
+      </p:sp>
+      <p:sp>
+        <p:nvSpPr>
+          <p:cNvPr id="9" name="TextBox 8"/>
+          <p:cNvSpPr txBox="1"/>
+          <p:nvPr/>
+        </p:nvSpPr>
+        <p:spPr>
+          <a:xfrm>
+            <a:off x="658368" y="5166360"/>
+            <a:ext cx="8686800" cy="365760"/>
+          </a:xfrm>
+          <a:prstGeom prst="rect">
+            <a:avLst/>
+          </a:prstGeom>
+          <a:noFill/>
+        </p:spPr>
+        <p:txBody>
+          <a:bodyPr wrap="square" anchor="t" lIns="0" rIns="0" tIns="0" bIns="0">
+            <a:spAutoFit/>
+          </a:bodyPr>
+          <a:lstStyle/>
+          <a:p>
+            <a:pPr algn="l"/>
+            <a:r>
+              <a:rPr sz="1800" b="1" i="0">
+                <a:solidFill>
+                  <a:srgbClr val="FFFFFF"/>
+                </a:solidFill>
+                <a:latin typeface="Aptos Display"/>
+              </a:rPr>
+              <a:t>Perguntas?</a:t>
+            </a:r>
+          </a:p>
+        </p:txBody>
+      </p:sp>
+      <p:cxnSp>
+        <p:nvCxnSpPr>
+          <p:cNvPr id="10" name="Connector 9"/>
+          <p:cNvCxnSpPr/>
+          <p:nvPr/>
+        </p:nvCxnSpPr>
+        <p:spPr>
+          <a:xfrm>
+            <a:off x="667512" y="5989320"/>
+            <a:ext cx="10853928" cy="0"/>
+          </a:xfrm>
+          <a:prstGeom prst="line">
+            <a:avLst/>
+          </a:prstGeom>
+          <a:ln w="9525">
+            <a:solidFill>
+              <a:srgbClr val="263951"/>
+            </a:solidFill>
+          </a:ln>
+          <a:effectLst/>
+        </p:spPr>
+        <p:style>
+          <a:lnRef idx="2">
+            <a:schemeClr val="accent1"/>
+          </a:lnRef>
+          <a:fillRef idx="0">
+            <a:schemeClr val="accent1"/>
+          </a:fillRef>
+          <a:effectRef idx="1">
+            <a:schemeClr val="accent1"/>
+          </a:effectRef>
+          <a:fontRef idx="minor">
+            <a:schemeClr val="tx1"/>
+          </a:fontRef>
+        </p:style>
+      </p:cxnSp>
+      <p:sp>
+        <p:nvSpPr>
+          <p:cNvPr id="11" name="TextBox 10"/>
+          <p:cNvSpPr txBox="1"/>
+          <p:nvPr/>
+        </p:nvSpPr>
+        <p:spPr>
+          <a:xfrm>
+            <a:off x="658368" y="6144768"/>
+            <a:ext cx="8229600" cy="274320"/>
+          </a:xfrm>
+          <a:prstGeom prst="rect">
+            <a:avLst/>
+          </a:prstGeom>
+          <a:noFill/>
+        </p:spPr>
+        <p:txBody>
+          <a:bodyPr wrap="square" anchor="t" lIns="0" rIns="0" tIns="0" bIns="0">
+            <a:spAutoFit/>
+          </a:bodyPr>
+          <a:lstStyle/>
+          <a:p>
+            <a:pPr algn="l"/>
+            <a:r>
+              <a:rPr sz="1050" b="0" i="0">
+                <a:solidFill>
+                  <a:srgbClr val="9FB0C6"/>
+                </a:solidFill>
+                <a:latin typeface="Aptos"/>
+              </a:rPr>
+              <a:t>Amanda Alves de Lima Santos  ·  Fábio da Silva Costa  ·  Gabriel Victor  ·  Vanessa Partala</a:t>
+            </a:r>
+          </a:p>
+        </p:txBody>
+      </p:sp>
+      <p:sp>
+        <p:nvSpPr>
+          <p:cNvPr id="12" name="TextBox 11"/>
+          <p:cNvSpPr txBox="1"/>
+          <p:nvPr/>
+        </p:nvSpPr>
+        <p:spPr>
+          <a:xfrm>
+            <a:off x="658368" y="6501384"/>
+            <a:ext cx="3749039" cy="164592"/>
+          </a:xfrm>
+          <a:prstGeom prst="rect">
+            <a:avLst/>
+          </a:prstGeom>
+          <a:noFill/>
+        </p:spPr>
+        <p:txBody>
+          <a:bodyPr wrap="square" anchor="t" lIns="0" rIns="0" tIns="0" bIns="0">
+            <a:spAutoFit/>
+          </a:bodyPr>
+          <a:lstStyle/>
+          <a:p>
+            <a:pPr algn="l"/>
+            <a:r>
+              <a:rPr sz="850" b="0" i="0">
+                <a:solidFill>
+                  <a:srgbClr val="718399"/>
+                </a:solidFill>
+                <a:latin typeface="Aptos"/>
+              </a:rPr>
+              <a:t>NPS Preditivo  ·  Tech Challenge Fase 1</a:t>
+            </a:r>
+          </a:p>
+        </p:txBody>
+      </p:sp>
+      <p:sp>
+        <p:nvSpPr>
+          <p:cNvPr id="13" name="TextBox 12"/>
+          <p:cNvSpPr txBox="1"/>
+          <p:nvPr/>
+        </p:nvSpPr>
+        <p:spPr>
+          <a:xfrm>
+            <a:off x="11137392" y="6473952"/>
+            <a:ext cx="384048" cy="164592"/>
+          </a:xfrm>
+          <a:prstGeom prst="rect">
+            <a:avLst/>
+          </a:prstGeom>
+          <a:noFill/>
+        </p:spPr>
+        <p:txBody>
+          <a:bodyPr wrap="square" anchor="t" lIns="0" rIns="0" tIns="0" bIns="0">
+            <a:spAutoFit/>
+          </a:bodyPr>
+          <a:lstStyle/>
+          <a:p>
+            <a:pPr algn="r"/>
+            <a:r>
+              <a:rPr sz="850" b="0" i="0">
+                <a:solidFill>
+                  <a:srgbClr val="718399"/>
+                </a:solidFill>
+                <a:latin typeface="Aptos"/>
+              </a:rPr>
+              <a:t>11</a:t>
+            </a:r>
+          </a:p>
+        </p:txBody>
+      </p:sp>
+    </p:spTree>
+  </p:cSld>
+  <p:clrMapOvr>
+    <a:masterClrMapping/>
+  </p:clrMapOvr>
+</p:sld>
+</file>
+
 <file path=ppt/slides/slide2.xml><?xml version="1.0" encoding="utf-8"?>
 <p:sld xmlns:a="http://schemas.openxmlformats.org/drawingml/2006/main" xmlns:r="http://schemas.openxmlformats.org/officeDocument/2006/relationships" xmlns:p="http://schemas.openxmlformats.org/presentationml/2006/main">
   <p:cSld>

</xml_diff>

<commit_message>
Adiciona Humberto a lista da equipe na capa e encerramento dos slides
Co-Authored-By: Claude Sonnet 5 <noreply@anthropic.com>
</commit_message>
<xml_diff>
--- a/Tech_Challenge_Fase1.pptx
+++ b/Tech_Challenge_Fase1.pptx
@@ -5054,7 +5054,7 @@
                 </a:solidFill>
                 <a:latin typeface="Aptos"/>
               </a:rPr>
-              <a:t>Amanda Alves de Lima Santos  ·  Fábio da Silva Costa  ·  Gabriel Victor  ·  Vanessa Partala</a:t>
+              <a:t>Amanda Alves de Lima Santos  ·  Fábio da Silva Costa  ·  Gabriel Victor Santos Oliveira  ·  Vanessa Partala  ·  Humberto Henrique Alves Moreira dos Santos</a:t>
             </a:r>
           </a:p>
         </p:txBody>
@@ -7580,8 +7580,8 @@
         </p:nvSpPr>
         <p:spPr>
           <a:xfrm>
-            <a:off x="658368" y="6144768"/>
-            <a:ext cx="8229600" cy="274320"/>
+            <a:off x="658368" y="6089904"/>
+            <a:ext cx="8229600" cy="365760"/>
           </a:xfrm>
           <a:prstGeom prst="rect">
             <a:avLst/>
@@ -7596,13 +7596,13 @@
           <a:p>
             <a:pPr algn="l"/>
             <a:r>
-              <a:rPr sz="1050" b="0" i="0">
+              <a:rPr sz="950" b="0" i="0">
                 <a:solidFill>
                   <a:srgbClr val="9FB0C6"/>
                 </a:solidFill>
                 <a:latin typeface="Aptos"/>
               </a:rPr>
-              <a:t>Amanda Alves de Lima Santos  ·  Fábio da Silva Costa  ·  Gabriel Victor  ·  Vanessa Partala</a:t>
+              <a:t>Amanda Alves de Lima Santos  ·  Fábio da Silva Costa  ·  Gabriel Victor Santos Oliveira  ·  Vanessa Partala  ·  Humberto Henrique Alves Moreira dos Santos</a:t>
             </a:r>
           </a:p>
         </p:txBody>

</xml_diff>